<commit_message>
fix: Add always-ready to Bicep, add 3 diagram slides, verify demo questions
- Add alwaysReady HTTP instance to function-app.bicep to fix cold start timeout
- Add Architecture Overview, Request Flow, and Data Flow slides (now 8 slides)
- Trim demo questions to 5 clips + 5 remarks + 2 proofread, all verified against seeded data
- Update all docs (CLAUDE.md, README, ARCHITECTURE, HOW-I-WAS-BUILT)

Co-Authored-By: Claude Opus 4.6 (1M context) <noreply@anthropic.com>
</commit_message>
<xml_diff>
--- a/docs/demo-questions.pptx
+++ b/docs/demo-questions.pptx
@@ -3425,7 +3425,7 @@
               </a:defRPr>
             </a:pPr>
             <a:r>
-              <a:t>Starter from the talk track. Shows basic semantic search.</a:t>
+              <a:t>Starter. Hits the $26M Stop-Gap Solutions press release about 5,161 rural homes.</a:t>
             </a:r>
           </a:p>
         </p:txBody>
@@ -3622,7 +3622,7 @@
               </a:defRPr>
             </a:pPr>
             <a:r>
-              <a:t>Has the Governor said anything about rural internet access?</a:t>
+              <a:t>Any press releases about Hurricane Helene recovery?</a:t>
             </a:r>
           </a:p>
           <a:p>
@@ -3635,7 +3635,7 @@
               </a:defRPr>
             </a:pPr>
             <a:r>
-              <a:t>Semantic match: finds "broadband" articles even though the words don't overlap.</a:t>
+              <a:t>Hits the $8.5M small business infrastructure grants and WNC recovery clips.</a:t>
             </a:r>
           </a:p>
         </p:txBody>
@@ -3727,7 +3727,7 @@
               </a:defRPr>
             </a:pPr>
             <a:r>
-              <a:t>Any press releases about economic development or jobs?</a:t>
+              <a:t>What has the Governor said about law enforcement pay?</a:t>
             </a:r>
           </a:p>
           <a:p>
@@ -3740,7 +3740,7 @@
               </a:defRPr>
             </a:pPr>
             <a:r>
-              <a:t>Broad topic. Shows hybrid search combining meaning and keyword matching.</a:t>
+              <a:t>Hits Charlotte law enforcement raises clip and $1.4B Critical Needs Budget.</a:t>
             </a:r>
           </a:p>
         </p:txBody>
@@ -3832,7 +3832,7 @@
               </a:defRPr>
             </a:pPr>
             <a:r>
-              <a:t>What's in the news about Hurricane Helene recovery?</a:t>
+              <a:t>Any news about jobs or economic development?</a:t>
             </a:r>
           </a:p>
           <a:p>
@@ -3845,119 +3845,14 @@
               </a:defRPr>
             </a:pPr>
             <a:r>
-              <a:t>Timely topic. Matches western NC disaster recovery press releases.</a:t>
-            </a:r>
-          </a:p>
-        </p:txBody>
-      </p:sp>
-      <p:sp>
-        <p:nvSpPr>
-          <p:cNvPr id="14" name="Oval 13"/>
-          <p:cNvSpPr/>
-          <p:nvPr/>
-        </p:nvSpPr>
-        <p:spPr>
-          <a:xfrm>
-            <a:off x="548640" y="5586984"/>
-            <a:ext cx="320040" cy="320040"/>
-          </a:xfrm>
-          <a:prstGeom prst="ellipse">
-            <a:avLst/>
-          </a:prstGeom>
-          <a:solidFill>
-            <a:srgbClr val="0078D4"/>
-          </a:solidFill>
-          <a:ln>
-            <a:noFill/>
-          </a:ln>
-        </p:spPr>
-        <p:style>
-          <a:lnRef idx="1">
-            <a:schemeClr val="accent1"/>
-          </a:lnRef>
-          <a:fillRef idx="3">
-            <a:schemeClr val="accent1"/>
-          </a:fillRef>
-          <a:effectRef idx="2">
-            <a:schemeClr val="accent1"/>
-          </a:effectRef>
-          <a:fontRef idx="minor">
-            <a:schemeClr val="lt1"/>
-          </a:fontRef>
-        </p:style>
-        <p:txBody>
-          <a:bodyPr rtlCol="0" anchor="ctr"/>
-          <a:lstStyle/>
-          <a:p>
-            <a:pPr algn="ctr">
-              <a:defRPr sz="1300" b="1">
-                <a:solidFill>
-                  <a:srgbClr val="FFFFFF"/>
-                </a:solidFill>
-                <a:latin typeface="Segoe UI"/>
-              </a:defRPr>
-            </a:pPr>
-            <a:r>
-              <a:t>6</a:t>
-            </a:r>
-          </a:p>
-        </p:txBody>
-      </p:sp>
-      <p:sp>
-        <p:nvSpPr>
-          <p:cNvPr id="15" name="TextBox 14"/>
-          <p:cNvSpPr txBox="1"/>
-          <p:nvPr/>
-        </p:nvSpPr>
-        <p:spPr>
-          <a:xfrm>
-            <a:off x="1051560" y="5532120"/>
-            <a:ext cx="10515600" cy="749808"/>
-          </a:xfrm>
-          <a:prstGeom prst="rect">
-            <a:avLst/>
-          </a:prstGeom>
-          <a:noFill/>
-        </p:spPr>
-        <p:txBody>
-          <a:bodyPr wrap="square">
-            <a:spAutoFit/>
-          </a:bodyPr>
-          <a:lstStyle/>
-          <a:p>
-            <a:pPr>
-              <a:spcAft>
-                <a:spcPts val="200"/>
-              </a:spcAft>
-              <a:defRPr sz="1800" b="1">
-                <a:solidFill>
-                  <a:srgbClr val="1A1A1A"/>
-                </a:solidFill>
-                <a:latin typeface="Segoe UI"/>
-              </a:defRPr>
-            </a:pPr>
-            <a:r>
-              <a:t>Are there any clips about education or schools?</a:t>
-            </a:r>
-          </a:p>
-          <a:p>
-            <a:pPr>
-              <a:defRPr sz="1200">
-                <a:solidFill>
-                  <a:srgbClr val="666666"/>
-                </a:solidFill>
-                <a:latin typeface="Segoe UI"/>
-              </a:defRPr>
-            </a:pPr>
-            <a:r>
-              <a:t>Wide query — could match teacher pay, school safety, student wellbeing.</a:t>
-            </a:r>
-          </a:p>
-        </p:txBody>
-      </p:sp>
-      <p:sp>
-        <p:nvSpPr>
-          <p:cNvPr id="16" name="TextBox 15"/>
+              <a:t>Broad query. Hits PSA Airlines (400 jobs), rural listening tour, Students@Work.</a:t>
+            </a:r>
+          </a:p>
+        </p:txBody>
+      </p:sp>
+      <p:sp>
+        <p:nvSpPr>
+          <p:cNvPr id="14" name="TextBox 13"/>
           <p:cNvSpPr txBox="1"/>
           <p:nvPr/>
         </p:nvSpPr>
@@ -4208,7 +4103,7 @@
               </a:defRPr>
             </a:pPr>
             <a:r>
-              <a:t>Starter from the talk track. Hits the October column — mental health as public safety.</a:t>
+              <a:t>Starter. Hits October column — $195M public safety package, 1.8M adults with mental health conditions.</a:t>
             </a:r>
           </a:p>
         </p:txBody>
@@ -4313,7 +4208,7 @@
               </a:defRPr>
             </a:pPr>
             <a:r>
-              <a:t>Direct hit on the September column. Shows retrieval of specific policy language.</a:t>
+              <a:t>Direct hit on September column — Student Safety Task Force, cell phone legislation.</a:t>
             </a:r>
           </a:p>
         </p:txBody>
@@ -4405,7 +4300,7 @@
               </a:defRPr>
             </a:pPr>
             <a:r>
-              <a:t>How has the Governor talked about emergency preparedness and hurricane recovery?</a:t>
+              <a:t>How has the Governor talked about hurricane recovery?</a:t>
             </a:r>
           </a:p>
           <a:p>
@@ -4418,7 +4313,7 @@
               </a:defRPr>
             </a:pPr>
             <a:r>
-              <a:t>Pulls from August (prep) and November (Helene gratitude). Cross-speech synthesis.</a:t>
+              <a:t>Cross-speech: State of the State ($60B damages), August (prep), November (98% roads reopened).</a:t>
             </a:r>
           </a:p>
         </p:txBody>
@@ -4510,7 +4405,7 @@
               </a:defRPr>
             </a:pPr>
             <a:r>
-              <a:t>What has the Governor said about law enforcement and supporting police?</a:t>
+              <a:t>What has the Governor said about food banks and hunger?</a:t>
             </a:r>
           </a:p>
           <a:p>
@@ -4523,7 +4418,7 @@
               </a:defRPr>
             </a:pPr>
             <a:r>
-              <a:t>October column: $195M public safety package, raising officer salaries.</a:t>
+              <a:t>December column (MANNA, Second Harvest, SNAP cuts) + November (food banks).</a:t>
             </a:r>
           </a:p>
         </p:txBody>
@@ -4628,119 +4523,14 @@
               </a:defRPr>
             </a:pPr>
             <a:r>
-              <a:t>January column: America 250, Halifax Resolves, Bill of Rights. Rich synthesis.</a:t>
-            </a:r>
-          </a:p>
-        </p:txBody>
-      </p:sp>
-      <p:sp>
-        <p:nvSpPr>
-          <p:cNvPr id="14" name="Oval 13"/>
-          <p:cNvSpPr/>
-          <p:nvPr/>
-        </p:nvSpPr>
-        <p:spPr>
-          <a:xfrm>
-            <a:off x="548640" y="5586984"/>
-            <a:ext cx="320040" cy="320040"/>
-          </a:xfrm>
-          <a:prstGeom prst="ellipse">
-            <a:avLst/>
-          </a:prstGeom>
-          <a:solidFill>
-            <a:srgbClr val="107C10"/>
-          </a:solidFill>
-          <a:ln>
-            <a:noFill/>
-          </a:ln>
-        </p:spPr>
-        <p:style>
-          <a:lnRef idx="1">
-            <a:schemeClr val="accent1"/>
-          </a:lnRef>
-          <a:fillRef idx="3">
-            <a:schemeClr val="accent1"/>
-          </a:fillRef>
-          <a:effectRef idx="2">
-            <a:schemeClr val="accent1"/>
-          </a:effectRef>
-          <a:fontRef idx="minor">
-            <a:schemeClr val="lt1"/>
-          </a:fontRef>
-        </p:style>
-        <p:txBody>
-          <a:bodyPr rtlCol="0" anchor="ctr"/>
-          <a:lstStyle/>
-          <a:p>
-            <a:pPr algn="ctr">
-              <a:defRPr sz="1300" b="1">
-                <a:solidFill>
-                  <a:srgbClr val="FFFFFF"/>
-                </a:solidFill>
-                <a:latin typeface="Segoe UI"/>
-              </a:defRPr>
-            </a:pPr>
-            <a:r>
-              <a:t>6</a:t>
-            </a:r>
-          </a:p>
-        </p:txBody>
-      </p:sp>
-      <p:sp>
-        <p:nvSpPr>
-          <p:cNvPr id="15" name="TextBox 14"/>
-          <p:cNvSpPr txBox="1"/>
-          <p:nvPr/>
-        </p:nvSpPr>
-        <p:spPr>
-          <a:xfrm>
-            <a:off x="1051560" y="5532120"/>
-            <a:ext cx="10515600" cy="749808"/>
-          </a:xfrm>
-          <a:prstGeom prst="rect">
-            <a:avLst/>
-          </a:prstGeom>
-          <a:noFill/>
-        </p:spPr>
-        <p:txBody>
-          <a:bodyPr wrap="square">
-            <a:spAutoFit/>
-          </a:bodyPr>
-          <a:lstStyle/>
-          <a:p>
-            <a:pPr>
-              <a:spcAft>
-                <a:spcPts val="200"/>
-              </a:spcAft>
-              <a:defRPr sz="1800" b="1">
-                <a:solidFill>
-                  <a:srgbClr val="1A1A1A"/>
-                </a:solidFill>
-                <a:latin typeface="Segoe UI"/>
-              </a:defRPr>
-            </a:pPr>
-            <a:r>
-              <a:t>What has the Governor said about food insecurity and food banks?</a:t>
-            </a:r>
-          </a:p>
-          <a:p>
-            <a:pPr>
-              <a:defRPr sz="1200">
-                <a:solidFill>
-                  <a:srgbClr val="666666"/>
-                </a:solidFill>
-                <a:latin typeface="Segoe UI"/>
-              </a:defRPr>
-            </a:pPr>
-            <a:r>
-              <a:t>December column (MANNA, Second Harvest) + November (farmers). Quotes with citations.</a:t>
-            </a:r>
-          </a:p>
-        </p:txBody>
-      </p:sp>
-      <p:sp>
-        <p:nvSpPr>
-          <p:cNvPr id="16" name="TextBox 15"/>
+              <a:t>January column — America 250, Halifax Resolves, Moores Creek Bridge, Bill of Rights.</a:t>
+            </a:r>
+          </a:p>
+        </p:txBody>
+      </p:sp>
+      <p:sp>
+        <p:nvSpPr>
+          <p:cNvPr id="14" name="TextBox 13"/>
           <p:cNvSpPr txBox="1"/>
           <p:nvPr/>
         </p:nvSpPr>
@@ -5838,7 +5628,7 @@
               </a:defRPr>
             </a:pPr>
             <a:r>
-              <a:t>"Has the Governor said anything about rural internet access?"</a:t>
+              <a:t>"Any press releases about Hurricane Helene recovery?"</a:t>
             </a:r>
           </a:p>
         </p:txBody>
@@ -5874,7 +5664,7 @@
               </a:defRPr>
             </a:pPr>
             <a:r>
-              <a:t>The "wow" moment — semantic search finds "broadband" from "rural internet"</a:t>
+              <a:t>Shows the agent surfacing timely, relevant press releases</a:t>
             </a:r>
           </a:p>
         </p:txBody>
@@ -5999,7 +5789,7 @@
               </a:defRPr>
             </a:pPr>
             <a:r>
-              <a:t>"How has the Governor talked about emergency preparedness?"</a:t>
+              <a:t>"How has the Governor talked about hurricane recovery?"</a:t>
             </a:r>
           </a:p>
         </p:txBody>
@@ -6035,7 +5825,7 @@
               </a:defRPr>
             </a:pPr>
             <a:r>
-              <a:t>Cross-speech synthesis — pulls from August + November columns</a:t>
+              <a:t>Cross-speech synthesis — pulls from State of the State + August + November</a:t>
             </a:r>
           </a:p>
         </p:txBody>

</xml_diff>